<commit_message>
Deck: the title on two lines
Co-Authored-By: Claude Opus 5.5 <noreply@anthropic.com>
</commit_message>
<xml_diff>
--- a/submission/pdf/serve_technical_report.pptx
+++ b/submission/pdf/serve_technical_report.pptx
@@ -3367,7 +3367,21 @@
                   <a:schemeClr val="bg1"/>
                 </a:solidFill>
               </a:rPr>
-              <a:t>Serve: Play more. Manage less.</a:t>
+              <a:t>Serve: Play more.</a:t>
+            </a:r>
+            <a:endParaRPr lang="en-US" sz="4800" dirty="0"/>
+          </a:p>
+          <a:p>
+            <a:pPr algn="l" indent="0" marL="0">
+              <a:buNone/>
+            </a:pPr>
+            <a:r>
+              <a:rPr lang="en-US" sz="4800" b="1" dirty="0">
+                <a:solidFill>
+                  <a:schemeClr val="bg1"/>
+                </a:solidFill>
+              </a:rPr>
+              <a:t>Manage less.</a:t>
             </a:r>
             <a:endParaRPr lang="en-US" sz="4800" dirty="0"/>
           </a:p>

</xml_diff>